<commit_message>
Align slide 4 background with change-management programs
Co-Authored-By: Claude Opus 5.5 <noreply@anthropic.com>
Claude-Session: https://claude.ai/code/session_014bmYQ2fMPYk9mSnunBW5W4
</commit_message>
<xml_diff>
--- a/27_중점과제_AX변화관리실행.pptx
+++ b/27_중점과제_AX변화관리실행.pptx
@@ -1114,7 +1114,7 @@
                   <a:srgbClr val="262626"/>
                 </a:solidFill>
               </a:rPr>
-              <a:t>추진 배경 및 방향</a:t>
+              <a:t>추진 배경</a:t>
             </a:r>
             <a:endParaRPr lang="en-US" sz="1500" dirty="0"/>
           </a:p>
@@ -1202,7 +1202,7 @@
                   <a:srgbClr val="FFFFFF"/>
                 </a:solidFill>
               </a:rPr>
-              <a:t>AX 변화관리 실행 방안</a:t>
+              <a:t>AX 변화관리 방안</a:t>
             </a:r>
             <a:endParaRPr lang="en-US" sz="1500" dirty="0"/>
           </a:p>
@@ -1270,7 +1270,7 @@
                   <a:srgbClr val="262626"/>
                 </a:solidFill>
               </a:rPr>
-              <a:t>AI 보급 및 1회성 교육 → 지속적인 AX 실행 체계 구축 필요</a:t>
+              <a:t>AI 단발성 교육 → 지속적인 AX 역량·실행 체계 필요</a:t>
             </a:r>
             <a:endParaRPr lang="en-US" sz="1300" dirty="0"/>
           </a:p>
@@ -1317,7 +1317,7 @@
                   <a:srgbClr val="262626"/>
                 </a:solidFill>
               </a:rPr>
-              <a:t>리터러시 확산 이후 핵심 과제는 </a:t>
+              <a:t>리터러시는 확산됐으나 </a:t>
             </a:r>
             <a:pPr indent="0" marL="0">
               <a:buNone/>
@@ -1328,7 +1328,18 @@
                   <a:srgbClr val="1F3FA8"/>
                 </a:solidFill>
               </a:rPr>
-              <a:t>AI 중심의 업무 재설계와 성과 창출</a:t>
+              <a:t>AI 중심 업무 재설계·성과 창출</a:t>
+            </a:r>
+            <a:pPr indent="0" marL="0">
+              <a:buNone/>
+            </a:pPr>
+            <a:r>
+              <a:rPr lang="en-US" sz="1150" b="1" dirty="0">
+                <a:solidFill>
+                  <a:srgbClr val="262626"/>
+                </a:solidFill>
+              </a:rPr>
+              <a:t>로 미연결</a:t>
             </a:r>
             <a:endParaRPr lang="en-US" sz="1150" dirty="0"/>
           </a:p>
@@ -1411,7 +1422,7 @@
                   <a:srgbClr val="262626"/>
                 </a:solidFill>
               </a:rPr>
-              <a:t>성과 창출의 핵심은 </a:t>
+              <a:t>성과 창출을 위해 </a:t>
             </a:r>
             <a:pPr indent="0" marL="0">
               <a:buNone/>
@@ -1422,7 +1433,18 @@
                   <a:srgbClr val="1F3FA8"/>
                 </a:solidFill>
               </a:rPr>
-              <a:t>구성원의 AI 활용 역량과 현장 변화관리</a:t>
+              <a:t>AI 활용 역량 확보와 현장 변화관리</a:t>
+            </a:r>
+            <a:pPr indent="0" marL="0">
+              <a:buNone/>
+            </a:pPr>
+            <a:r>
+              <a:rPr lang="en-US" sz="1150" b="1" dirty="0">
+                <a:solidFill>
+                  <a:srgbClr val="262626"/>
+                </a:solidFill>
+              </a:rPr>
+              <a:t>를 함께 추진</a:t>
             </a:r>
             <a:endParaRPr lang="en-US" sz="1150" dirty="0"/>
           </a:p>
@@ -1458,7 +1480,7 @@
                   <a:srgbClr val="262626"/>
                 </a:solidFill>
               </a:rPr>
-              <a:t>※ 주요 그룹은 공통 AI 역량 기준·제도 운영과 현장 정착 지원을 병행</a:t>
+              <a:t>- 주요 그룹은 공통 AI 역량 교육·인증과 현장 정착 지원을 병행</a:t>
             </a:r>
             <a:endParaRPr lang="en-US" sz="1050" dirty="0"/>
           </a:p>
@@ -2121,7 +2143,7 @@
                   <a:srgbClr val="262626"/>
                 </a:solidFill>
               </a:rPr>
-              <a:t>그룹 공통 AI 교육 프로그램</a:t>
+              <a:t>그룹 공통 AI 프로그램</a:t>
             </a:r>
             <a:endParaRPr lang="en-US" sz="1150" dirty="0"/>
           </a:p>
@@ -2346,7 +2368,7 @@
                   <a:srgbClr val="262626"/>
                 </a:solidFill>
               </a:rPr>
-              <a:t>현업 AI Use Case 도출</a:t>
+              <a:t>현업 교육으로 AI 니즈 수집</a:t>
             </a:r>
             <a:endParaRPr lang="en-US" sz="1050" dirty="0"/>
           </a:p>
@@ -2360,7 +2382,7 @@
                   <a:srgbClr val="262626"/>
                 </a:solidFill>
               </a:rPr>
-              <a:t>→ FDE 방식으로 실행 연계</a:t>
+              <a:t>→ FDE 방식으로 과제 선제안</a:t>
             </a:r>
             <a:endParaRPr lang="en-US" sz="1050" dirty="0"/>
           </a:p>
@@ -2468,7 +2490,7 @@
                   <a:srgbClr val="1F3FA8"/>
                 </a:solidFill>
               </a:rPr>
-              <a:t>현장 사례 · Agent를 교육 콘텐츠에 환류</a:t>
+              <a:t>현장 사례 · Agent를 교육 콘텐츠에 반영</a:t>
             </a:r>
             <a:endParaRPr lang="en-US" sz="950" dirty="0"/>
           </a:p>
@@ -2594,7 +2616,7 @@
                   <a:srgbClr val="1F3FA8"/>
                 </a:solidFill>
               </a:rPr>
-              <a:t>AX컨설팅팀이 맞춤 콘텐츠·실습 시나리오·환경 제공</a:t>
+              <a:t>AX컨설팅팀 맞춤 콘텐츠·실습 시나리오 제공</a:t>
             </a:r>
             <a:endParaRPr lang="en-US" sz="1100" dirty="0"/>
           </a:p>

</xml_diff>